<commit_message>
added last 3 regions and updated for review
</commit_message>
<xml_diff>
--- a/figs/figures.pptx
+++ b/figs/figures.pptx
@@ -198,7 +198,7 @@
           <a:p>
             <a:fld id="{9088784E-7603-884D-8785-F98637566DBB}" type="datetimeFigureOut">
               <a:rPr lang="en-US" smtClean="0"/>
-              <a:t>8/13/25</a:t>
+              <a:t>9/11/25</a:t>
             </a:fld>
             <a:endParaRPr lang="en-US"/>
           </a:p>
@@ -780,7 +780,7 @@
           <a:p>
             <a:fld id="{D8914414-2A77-FC4C-88A1-A9A8211F05BC}" type="datetimeFigureOut">
               <a:rPr lang="en-US" smtClean="0"/>
-              <a:t>8/13/25</a:t>
+              <a:t>9/11/25</a:t>
             </a:fld>
             <a:endParaRPr lang="en-US"/>
           </a:p>
@@ -978,7 +978,7 @@
           <a:p>
             <a:fld id="{D8914414-2A77-FC4C-88A1-A9A8211F05BC}" type="datetimeFigureOut">
               <a:rPr lang="en-US" smtClean="0"/>
-              <a:t>8/13/25</a:t>
+              <a:t>9/11/25</a:t>
             </a:fld>
             <a:endParaRPr lang="en-US"/>
           </a:p>
@@ -1186,7 +1186,7 @@
           <a:p>
             <a:fld id="{D8914414-2A77-FC4C-88A1-A9A8211F05BC}" type="datetimeFigureOut">
               <a:rPr lang="en-US" smtClean="0"/>
-              <a:t>8/13/25</a:t>
+              <a:t>9/11/25</a:t>
             </a:fld>
             <a:endParaRPr lang="en-US"/>
           </a:p>
@@ -1384,7 +1384,7 @@
           <a:p>
             <a:fld id="{D8914414-2A77-FC4C-88A1-A9A8211F05BC}" type="datetimeFigureOut">
               <a:rPr lang="en-US" smtClean="0"/>
-              <a:t>8/13/25</a:t>
+              <a:t>9/11/25</a:t>
             </a:fld>
             <a:endParaRPr lang="en-US"/>
           </a:p>
@@ -1659,7 +1659,7 @@
           <a:p>
             <a:fld id="{D8914414-2A77-FC4C-88A1-A9A8211F05BC}" type="datetimeFigureOut">
               <a:rPr lang="en-US" smtClean="0"/>
-              <a:t>8/13/25</a:t>
+              <a:t>9/11/25</a:t>
             </a:fld>
             <a:endParaRPr lang="en-US"/>
           </a:p>
@@ -1924,7 +1924,7 @@
           <a:p>
             <a:fld id="{D8914414-2A77-FC4C-88A1-A9A8211F05BC}" type="datetimeFigureOut">
               <a:rPr lang="en-US" smtClean="0"/>
-              <a:t>8/13/25</a:t>
+              <a:t>9/11/25</a:t>
             </a:fld>
             <a:endParaRPr lang="en-US"/>
           </a:p>
@@ -2336,7 +2336,7 @@
           <a:p>
             <a:fld id="{D8914414-2A77-FC4C-88A1-A9A8211F05BC}" type="datetimeFigureOut">
               <a:rPr lang="en-US" smtClean="0"/>
-              <a:t>8/13/25</a:t>
+              <a:t>9/11/25</a:t>
             </a:fld>
             <a:endParaRPr lang="en-US"/>
           </a:p>
@@ -2477,7 +2477,7 @@
           <a:p>
             <a:fld id="{D8914414-2A77-FC4C-88A1-A9A8211F05BC}" type="datetimeFigureOut">
               <a:rPr lang="en-US" smtClean="0"/>
-              <a:t>8/13/25</a:t>
+              <a:t>9/11/25</a:t>
             </a:fld>
             <a:endParaRPr lang="en-US"/>
           </a:p>
@@ -2590,7 +2590,7 @@
           <a:p>
             <a:fld id="{D8914414-2A77-FC4C-88A1-A9A8211F05BC}" type="datetimeFigureOut">
               <a:rPr lang="en-US" smtClean="0"/>
-              <a:t>8/13/25</a:t>
+              <a:t>9/11/25</a:t>
             </a:fld>
             <a:endParaRPr lang="en-US"/>
           </a:p>
@@ -2901,7 +2901,7 @@
           <a:p>
             <a:fld id="{D8914414-2A77-FC4C-88A1-A9A8211F05BC}" type="datetimeFigureOut">
               <a:rPr lang="en-US" smtClean="0"/>
-              <a:t>8/13/25</a:t>
+              <a:t>9/11/25</a:t>
             </a:fld>
             <a:endParaRPr lang="en-US"/>
           </a:p>
@@ -3189,7 +3189,7 @@
           <a:p>
             <a:fld id="{D8914414-2A77-FC4C-88A1-A9A8211F05BC}" type="datetimeFigureOut">
               <a:rPr lang="en-US" smtClean="0"/>
-              <a:t>8/13/25</a:t>
+              <a:t>9/11/25</a:t>
             </a:fld>
             <a:endParaRPr lang="en-US"/>
           </a:p>
@@ -3430,7 +3430,7 @@
           <a:p>
             <a:fld id="{D8914414-2A77-FC4C-88A1-A9A8211F05BC}" type="datetimeFigureOut">
               <a:rPr lang="en-US" smtClean="0"/>
-              <a:t>8/13/25</a:t>
+              <a:t>9/11/25</a:t>
             </a:fld>
             <a:endParaRPr lang="en-US"/>
           </a:p>
@@ -25058,12 +25058,311 @@
           </a:p>
         </p:txBody>
       </p:sp>
+      <p:pic>
+        <p:nvPicPr>
+          <p:cNvPr id="51" name="Picture 2">
+            <a:extLst>
+              <a:ext uri="{FF2B5EF4-FFF2-40B4-BE49-F238E27FC236}">
+                <a16:creationId xmlns:a16="http://schemas.microsoft.com/office/drawing/2014/main" id="{090AD3AA-827F-5E3B-35F4-C40CA89B0998}"/>
+              </a:ext>
+            </a:extLst>
+          </p:cNvPr>
+          <p:cNvPicPr>
+            <a:picLocks noChangeAspect="1" noChangeArrowheads="1"/>
+          </p:cNvPicPr>
+          <p:nvPr/>
+        </p:nvPicPr>
+        <p:blipFill rotWithShape="1">
+          <a:blip r:embed="rId6">
+            <a:grayscl/>
+            <a:alphaModFix/>
+            <a:extLst>
+              <a:ext uri="{BEBA8EAE-BF5A-486C-A8C5-ECC9F3942E4B}">
+                <a14:imgProps xmlns:a14="http://schemas.microsoft.com/office/drawing/2010/main">
+                  <a14:imgLayer r:embed="rId7">
+                    <a14:imgEffect>
+                      <a14:colorTemperature colorTemp="4700"/>
+                    </a14:imgEffect>
+                    <a14:imgEffect>
+                      <a14:saturation sat="0"/>
+                    </a14:imgEffect>
+                  </a14:imgLayer>
+                </a14:imgProps>
+              </a:ext>
+              <a:ext uri="{28A0092B-C50C-407E-A947-70E740481C1C}">
+                <a14:useLocalDpi xmlns:a14="http://schemas.microsoft.com/office/drawing/2010/main" val="0"/>
+              </a:ext>
+            </a:extLst>
+          </a:blip>
+          <a:srcRect t="5365"/>
+          <a:stretch>
+            <a:fillRect/>
+          </a:stretch>
+        </p:blipFill>
+        <p:spPr bwMode="auto">
+          <a:xfrm>
+            <a:off x="689927" y="2868826"/>
+            <a:ext cx="5294259" cy="3763536"/>
+          </a:xfrm>
+          <a:prstGeom prst="rect">
+            <a:avLst/>
+          </a:prstGeom>
+          <a:noFill/>
+          <a:extLst>
+            <a:ext uri="{909E8E84-426E-40DD-AFC4-6F175D3DCCD1}">
+              <a14:hiddenFill xmlns:a14="http://schemas.microsoft.com/office/drawing/2010/main">
+                <a:solidFill>
+                  <a:srgbClr val="FFFFFF"/>
+                </a:solidFill>
+              </a14:hiddenFill>
+            </a:ext>
+          </a:extLst>
+        </p:spPr>
+      </p:pic>
+      <p:pic>
+        <p:nvPicPr>
+          <p:cNvPr id="52" name="Picture 4">
+            <a:extLst>
+              <a:ext uri="{FF2B5EF4-FFF2-40B4-BE49-F238E27FC236}">
+                <a16:creationId xmlns:a16="http://schemas.microsoft.com/office/drawing/2014/main" id="{486C646E-5E27-B5CD-8934-94ED5B3DEA12}"/>
+              </a:ext>
+            </a:extLst>
+          </p:cNvPr>
+          <p:cNvPicPr>
+            <a:picLocks noChangeAspect="1" noChangeArrowheads="1"/>
+          </p:cNvPicPr>
+          <p:nvPr/>
+        </p:nvPicPr>
+        <p:blipFill rotWithShape="1">
+          <a:blip r:embed="rId8">
+            <a:duotone>
+              <a:prstClr val="black"/>
+              <a:schemeClr val="accent6">
+                <a:lumMod val="40000"/>
+                <a:lumOff val="60000"/>
+                <a:tint val="45000"/>
+                <a:satMod val="400000"/>
+              </a:schemeClr>
+            </a:duotone>
+            <a:extLst>
+              <a:ext uri="{BEBA8EAE-BF5A-486C-A8C5-ECC9F3942E4B}">
+                <a14:imgProps xmlns:a14="http://schemas.microsoft.com/office/drawing/2010/main">
+                  <a14:imgLayer r:embed="rId9">
+                    <a14:imgEffect>
+                      <a14:backgroundRemoval t="32813" b="65938" l="1526" r="16315">
+                        <a14:foregroundMark x1="2347" y1="35313" x2="4930" y2="34688"/>
+                        <a14:foregroundMark x1="9038" y1="63438" x2="13850" y2="67188"/>
+                        <a14:foregroundMark x1="13850" y1="67188" x2="16315" y2="60625"/>
+                        <a14:foregroundMark x1="16315" y1="60625" x2="15258" y2="57969"/>
+                        <a14:foregroundMark x1="9859" y1="65781" x2="15141" y2="65938"/>
+                        <a14:foregroundMark x1="3052" y1="33125" x2="4108" y2="32813"/>
+                      </a14:backgroundRemoval>
+                    </a14:imgEffect>
+                    <a14:imgEffect>
+                      <a14:brightnessContrast bright="20000"/>
+                    </a14:imgEffect>
+                  </a14:imgLayer>
+                </a14:imgProps>
+              </a:ext>
+              <a:ext uri="{28A0092B-C50C-407E-A947-70E740481C1C}">
+                <a14:useLocalDpi xmlns:a14="http://schemas.microsoft.com/office/drawing/2010/main" val="0"/>
+              </a:ext>
+            </a:extLst>
+          </a:blip>
+          <a:srcRect t="30786" r="83068" b="31542"/>
+          <a:stretch>
+            <a:fillRect/>
+          </a:stretch>
+        </p:blipFill>
+        <p:spPr bwMode="auto">
+          <a:xfrm>
+            <a:off x="689927" y="3876614"/>
+            <a:ext cx="896453" cy="1498208"/>
+          </a:xfrm>
+          <a:prstGeom prst="rect">
+            <a:avLst/>
+          </a:prstGeom>
+          <a:noFill/>
+          <a:extLst>
+            <a:ext uri="{909E8E84-426E-40DD-AFC4-6F175D3DCCD1}">
+              <a14:hiddenFill xmlns:a14="http://schemas.microsoft.com/office/drawing/2010/main">
+                <a:solidFill>
+                  <a:srgbClr val="FFFFFF"/>
+                </a:solidFill>
+              </a14:hiddenFill>
+            </a:ext>
+          </a:extLst>
+        </p:spPr>
+      </p:pic>
+      <p:pic>
+        <p:nvPicPr>
+          <p:cNvPr id="53" name="Picture 4">
+            <a:extLst>
+              <a:ext uri="{FF2B5EF4-FFF2-40B4-BE49-F238E27FC236}">
+                <a16:creationId xmlns:a16="http://schemas.microsoft.com/office/drawing/2014/main" id="{C4AC6C9D-920D-BEA8-F549-FF5A9F8A070B}"/>
+              </a:ext>
+            </a:extLst>
+          </p:cNvPr>
+          <p:cNvPicPr>
+            <a:picLocks noChangeAspect="1" noChangeArrowheads="1"/>
+          </p:cNvPicPr>
+          <p:nvPr/>
+        </p:nvPicPr>
+        <p:blipFill rotWithShape="1">
+          <a:blip r:embed="rId10">
+            <a:alphaModFix/>
+            <a:duotone>
+              <a:prstClr val="black"/>
+              <a:schemeClr val="accent6">
+                <a:lumMod val="40000"/>
+                <a:lumOff val="60000"/>
+                <a:tint val="45000"/>
+                <a:satMod val="400000"/>
+              </a:schemeClr>
+            </a:duotone>
+            <a:extLst>
+              <a:ext uri="{BEBA8EAE-BF5A-486C-A8C5-ECC9F3942E4B}">
+                <a14:imgProps xmlns:a14="http://schemas.microsoft.com/office/drawing/2010/main">
+                  <a14:imgLayer r:embed="rId11">
+                    <a14:imgEffect>
+                      <a14:backgroundRemoval t="36094" b="56875" l="70775" r="89789">
+                        <a14:foregroundMark x1="83398" y1="36518" x2="84390" y2="36406"/>
+                        <a14:foregroundMark x1="78873" y1="37031" x2="79385" y2="36973"/>
+                        <a14:foregroundMark x1="84390" y1="36406" x2="90023" y2="37500"/>
+                        <a14:foregroundMark x1="90023" y1="37500" x2="88732" y2="52344"/>
+                        <a14:foregroundMark x1="88732" y1="52344" x2="78987" y2="56524"/>
+                        <a14:foregroundMark x1="77013" y1="56515" x2="72653" y2="55156"/>
+                        <a14:foregroundMark x1="72653" y1="55156" x2="71831" y2="49375"/>
+                        <a14:foregroundMark x1="83685" y1="36094" x2="87559" y2="36250"/>
+                        <a14:foregroundMark x1="87911" y1="36719" x2="89789" y2="43906"/>
+                        <a14:foregroundMark x1="89789" y1="43906" x2="88732" y2="43906"/>
+                        <a14:backgroundMark x1="79577" y1="36563" x2="83451" y2="36406"/>
+                        <a14:backgroundMark x1="77934" y1="57813" x2="77934" y2="57813"/>
+                        <a14:backgroundMark x1="78052" y1="57500" x2="78638" y2="57344"/>
+                        <a14:backgroundMark x1="78052" y1="57500" x2="78052" y2="57500"/>
+                        <a14:backgroundMark x1="78052" y1="57500" x2="77700" y2="57656"/>
+                        <a14:backgroundMark x1="78169" y1="57813" x2="78052" y2="57500"/>
+                        <a14:backgroundMark x1="78052" y1="57344" x2="78052" y2="57344"/>
+                        <a14:backgroundMark x1="78286" y1="57813" x2="77934" y2="57656"/>
+                        <a14:backgroundMark x1="78169" y1="57188" x2="77700" y2="57344"/>
+                      </a14:backgroundRemoval>
+                    </a14:imgEffect>
+                    <a14:imgEffect>
+                      <a14:brightnessContrast bright="20000"/>
+                    </a14:imgEffect>
+                  </a14:imgLayer>
+                </a14:imgProps>
+              </a:ext>
+              <a:ext uri="{28A0092B-C50C-407E-A947-70E740481C1C}">
+                <a14:useLocalDpi xmlns:a14="http://schemas.microsoft.com/office/drawing/2010/main" val="0"/>
+              </a:ext>
+            </a:extLst>
+          </a:blip>
+          <a:srcRect l="68759" t="35021" r="9163" b="41374"/>
+          <a:stretch>
+            <a:fillRect/>
+          </a:stretch>
+        </p:blipFill>
+        <p:spPr bwMode="auto">
+          <a:xfrm>
+            <a:off x="4333577" y="4049467"/>
+            <a:ext cx="1168867" cy="938727"/>
+          </a:xfrm>
+          <a:prstGeom prst="rect">
+            <a:avLst/>
+          </a:prstGeom>
+          <a:noFill/>
+          <a:extLst>
+            <a:ext uri="{909E8E84-426E-40DD-AFC4-6F175D3DCCD1}">
+              <a14:hiddenFill xmlns:a14="http://schemas.microsoft.com/office/drawing/2010/main">
+                <a:solidFill>
+                  <a:srgbClr val="FFFFFF"/>
+                </a:solidFill>
+              </a14:hiddenFill>
+            </a:ext>
+          </a:extLst>
+        </p:spPr>
+      </p:pic>
+      <p:pic>
+        <p:nvPicPr>
+          <p:cNvPr id="54" name="Picture 4">
+            <a:extLst>
+              <a:ext uri="{FF2B5EF4-FFF2-40B4-BE49-F238E27FC236}">
+                <a16:creationId xmlns:a16="http://schemas.microsoft.com/office/drawing/2014/main" id="{559C3ED2-9BF4-8384-0090-FED13B4EC30B}"/>
+              </a:ext>
+            </a:extLst>
+          </p:cNvPr>
+          <p:cNvPicPr>
+            <a:picLocks noChangeAspect="1" noChangeArrowheads="1"/>
+          </p:cNvPicPr>
+          <p:nvPr/>
+        </p:nvPicPr>
+        <p:blipFill rotWithShape="1">
+          <a:blip r:embed="rId12">
+            <a:duotone>
+              <a:prstClr val="black"/>
+              <a:schemeClr val="accent6">
+                <a:lumMod val="40000"/>
+                <a:lumOff val="60000"/>
+                <a:tint val="45000"/>
+                <a:satMod val="400000"/>
+              </a:schemeClr>
+            </a:duotone>
+            <a:extLst>
+              <a:ext uri="{BEBA8EAE-BF5A-486C-A8C5-ECC9F3942E4B}">
+                <a14:imgProps xmlns:a14="http://schemas.microsoft.com/office/drawing/2010/main">
+                  <a14:imgLayer r:embed="rId13">
+                    <a14:imgEffect>
+                      <a14:backgroundRemoval t="65625" b="96250" l="32512" r="54343">
+                        <a14:foregroundMark x1="32512" y1="77813" x2="33216" y2="74063"/>
+                        <a14:foregroundMark x1="41784" y1="68594" x2="47066" y2="67969"/>
+                        <a14:foregroundMark x1="41315" y1="65781" x2="43192" y2="66250"/>
+                        <a14:foregroundMark x1="54343" y1="78125" x2="54343" y2="78125"/>
+                        <a14:backgroundMark x1="54577" y1="72344" x2="54108" y2="71719"/>
+                      </a14:backgroundRemoval>
+                    </a14:imgEffect>
+                    <a14:imgEffect>
+                      <a14:brightnessContrast bright="20000"/>
+                    </a14:imgEffect>
+                  </a14:imgLayer>
+                </a14:imgProps>
+              </a:ext>
+              <a:ext uri="{28A0092B-C50C-407E-A947-70E740481C1C}">
+                <a14:useLocalDpi xmlns:a14="http://schemas.microsoft.com/office/drawing/2010/main" val="0"/>
+              </a:ext>
+            </a:extLst>
+          </a:blip>
+          <a:srcRect l="30337" t="64817" r="43811"/>
+          <a:stretch>
+            <a:fillRect/>
+          </a:stretch>
+        </p:blipFill>
+        <p:spPr bwMode="auto">
+          <a:xfrm>
+            <a:off x="2295197" y="5228572"/>
+            <a:ext cx="1368664" cy="1399173"/>
+          </a:xfrm>
+          <a:prstGeom prst="rect">
+            <a:avLst/>
+          </a:prstGeom>
+          <a:noFill/>
+          <a:extLst>
+            <a:ext uri="{909E8E84-426E-40DD-AFC4-6F175D3DCCD1}">
+              <a14:hiddenFill xmlns:a14="http://schemas.microsoft.com/office/drawing/2010/main">
+                <a:solidFill>
+                  <a:srgbClr val="FFFFFF"/>
+                </a:solidFill>
+              </a14:hiddenFill>
+            </a:ext>
+          </a:extLst>
+        </p:spPr>
+      </p:pic>
       <p:grpSp>
         <p:nvGrpSpPr>
-          <p:cNvPr id="31" name="Group 30">
+          <p:cNvPr id="33" name="Group 32">
             <a:extLst>
               <a:ext uri="{FF2B5EF4-FFF2-40B4-BE49-F238E27FC236}">
-                <a16:creationId xmlns:a16="http://schemas.microsoft.com/office/drawing/2014/main" id="{2F3C2BDE-D641-77A7-B487-5B55D25A953F}"/>
+                <a16:creationId xmlns:a16="http://schemas.microsoft.com/office/drawing/2014/main" id="{731D8716-A697-8A1E-347D-61F2D6A8FD5D}"/>
               </a:ext>
             </a:extLst>
           </p:cNvPr>
@@ -25072,745 +25371,444 @@
         </p:nvGrpSpPr>
         <p:grpSpPr>
           <a:xfrm>
-            <a:off x="366105" y="2868826"/>
-            <a:ext cx="6143806" cy="3869905"/>
-            <a:chOff x="336001" y="3031639"/>
-            <a:chExt cx="5995283" cy="3776352"/>
+            <a:off x="5443220" y="4243723"/>
+            <a:ext cx="1066691" cy="985850"/>
+            <a:chOff x="5332830" y="4387474"/>
+            <a:chExt cx="1040904" cy="962018"/>
           </a:xfrm>
         </p:grpSpPr>
-        <p:grpSp>
-          <p:nvGrpSpPr>
-            <p:cNvPr id="32" name="Group 31">
+        <p:pic>
+          <p:nvPicPr>
+            <p:cNvPr id="49" name="Picture 5">
               <a:extLst>
                 <a:ext uri="{FF2B5EF4-FFF2-40B4-BE49-F238E27FC236}">
-                  <a16:creationId xmlns:a16="http://schemas.microsoft.com/office/drawing/2014/main" id="{A86DDB91-8645-946E-615C-71EB1C3CC340}"/>
+                  <a16:creationId xmlns:a16="http://schemas.microsoft.com/office/drawing/2014/main" id="{A7D501B2-6705-DF49-171E-A018ED309F8C}"/>
                 </a:ext>
               </a:extLst>
             </p:cNvPr>
-            <p:cNvGrpSpPr/>
+            <p:cNvPicPr>
+              <a:picLocks noChangeAspect="1" noChangeArrowheads="1"/>
+            </p:cNvPicPr>
             <p:nvPr/>
-          </p:nvGrpSpPr>
-          <p:grpSpPr>
-            <a:xfrm>
-              <a:off x="651995" y="3031639"/>
-              <a:ext cx="5166273" cy="3672554"/>
-              <a:chOff x="1288029" y="1248053"/>
-              <a:chExt cx="8595100" cy="6110010"/>
-            </a:xfrm>
-          </p:grpSpPr>
-          <p:pic>
-            <p:nvPicPr>
-              <p:cNvPr id="51" name="Picture 2">
-                <a:extLst>
-                  <a:ext uri="{FF2B5EF4-FFF2-40B4-BE49-F238E27FC236}">
-                    <a16:creationId xmlns:a16="http://schemas.microsoft.com/office/drawing/2014/main" id="{090AD3AA-827F-5E3B-35F4-C40CA89B0998}"/>
-                  </a:ext>
-                </a:extLst>
-              </p:cNvPr>
-              <p:cNvPicPr>
-                <a:picLocks noChangeAspect="1" noChangeArrowheads="1"/>
-              </p:cNvPicPr>
-              <p:nvPr/>
-            </p:nvPicPr>
-            <p:blipFill rotWithShape="1">
-              <a:blip r:embed="rId6">
-                <a:alphaModFix/>
-                <a:grayscl/>
-                <a:extLst>
-                  <a:ext uri="{BEBA8EAE-BF5A-486C-A8C5-ECC9F3942E4B}">
-                    <a14:imgProps xmlns:a14="http://schemas.microsoft.com/office/drawing/2010/main">
-                      <a14:imgLayer r:embed="rId7">
-                        <a14:imgEffect>
-                          <a14:saturation sat="0"/>
-                        </a14:imgEffect>
-                      </a14:imgLayer>
-                    </a14:imgProps>
-                  </a:ext>
-                  <a:ext uri="{28A0092B-C50C-407E-A947-70E740481C1C}">
-                    <a14:useLocalDpi xmlns:a14="http://schemas.microsoft.com/office/drawing/2010/main" val="0"/>
-                  </a:ext>
-                </a:extLst>
-              </a:blip>
-              <a:srcRect t="5365"/>
-              <a:stretch>
-                <a:fillRect/>
-              </a:stretch>
-            </p:blipFill>
-            <p:spPr bwMode="auto">
-              <a:xfrm>
-                <a:off x="1288029" y="1248053"/>
-                <a:ext cx="8595100" cy="6110010"/>
-              </a:xfrm>
-              <a:prstGeom prst="rect">
-                <a:avLst/>
-              </a:prstGeom>
-              <a:noFill/>
+          </p:nvPicPr>
+          <p:blipFill rotWithShape="1">
+            <a:blip r:embed="rId3">
               <a:extLst>
-                <a:ext uri="{909E8E84-426E-40DD-AFC4-6F175D3DCCD1}">
-                  <a14:hiddenFill xmlns:a14="http://schemas.microsoft.com/office/drawing/2010/main">
-                    <a:solidFill>
-                      <a:srgbClr val="FFFFFF"/>
-                    </a:solidFill>
-                  </a14:hiddenFill>
+                <a:ext uri="{28A0092B-C50C-407E-A947-70E740481C1C}">
+                  <a14:useLocalDpi xmlns:a14="http://schemas.microsoft.com/office/drawing/2010/main" val="0"/>
                 </a:ext>
               </a:extLst>
-            </p:spPr>
-          </p:pic>
-          <p:pic>
-            <p:nvPicPr>
-              <p:cNvPr id="52" name="Picture 4">
-                <a:extLst>
-                  <a:ext uri="{FF2B5EF4-FFF2-40B4-BE49-F238E27FC236}">
-                    <a16:creationId xmlns:a16="http://schemas.microsoft.com/office/drawing/2014/main" id="{486C646E-5E27-B5CD-8934-94ED5B3DEA12}"/>
-                  </a:ext>
-                </a:extLst>
-              </p:cNvPr>
-              <p:cNvPicPr>
-                <a:picLocks noChangeAspect="1" noChangeArrowheads="1"/>
-              </p:cNvPicPr>
-              <p:nvPr/>
-            </p:nvPicPr>
-            <p:blipFill rotWithShape="1">
-              <a:blip r:embed="rId8">
-                <a:extLst>
-                  <a:ext uri="{BEBA8EAE-BF5A-486C-A8C5-ECC9F3942E4B}">
-                    <a14:imgProps xmlns:a14="http://schemas.microsoft.com/office/drawing/2010/main">
-                      <a14:imgLayer r:embed="rId9">
-                        <a14:imgEffect>
-                          <a14:backgroundRemoval t="32813" b="65938" l="1526" r="16315">
-                            <a14:foregroundMark x1="2347" y1="35313" x2="4930" y2="34688"/>
-                            <a14:foregroundMark x1="9038" y1="63438" x2="13850" y2="67188"/>
-                            <a14:foregroundMark x1="13850" y1="67188" x2="16315" y2="60625"/>
-                            <a14:foregroundMark x1="16315" y1="60625" x2="15258" y2="57969"/>
-                            <a14:foregroundMark x1="9859" y1="65781" x2="15141" y2="65938"/>
-                            <a14:foregroundMark x1="3052" y1="33125" x2="4108" y2="32813"/>
-                          </a14:backgroundRemoval>
-                        </a14:imgEffect>
-                      </a14:imgLayer>
-                    </a14:imgProps>
-                  </a:ext>
-                  <a:ext uri="{28A0092B-C50C-407E-A947-70E740481C1C}">
-                    <a14:useLocalDpi xmlns:a14="http://schemas.microsoft.com/office/drawing/2010/main" val="0"/>
-                  </a:ext>
-                </a:extLst>
-              </a:blip>
-              <a:srcRect t="30786" r="83068" b="31542"/>
-              <a:stretch>
-                <a:fillRect/>
-              </a:stretch>
-            </p:blipFill>
-            <p:spPr bwMode="auto">
-              <a:xfrm>
-                <a:off x="1288029" y="2884172"/>
-                <a:ext cx="1455370" cy="2432304"/>
-              </a:xfrm>
-              <a:prstGeom prst="rect">
-                <a:avLst/>
-              </a:prstGeom>
-              <a:noFill/>
-              <a:extLst>
-                <a:ext uri="{909E8E84-426E-40DD-AFC4-6F175D3DCCD1}">
-                  <a14:hiddenFill xmlns:a14="http://schemas.microsoft.com/office/drawing/2010/main">
-                    <a:solidFill>
-                      <a:srgbClr val="FFFFFF"/>
-                    </a:solidFill>
-                  </a14:hiddenFill>
-                </a:ext>
-              </a:extLst>
-            </p:spPr>
-          </p:pic>
-          <p:pic>
-            <p:nvPicPr>
-              <p:cNvPr id="53" name="Picture 4">
-                <a:extLst>
-                  <a:ext uri="{FF2B5EF4-FFF2-40B4-BE49-F238E27FC236}">
-                    <a16:creationId xmlns:a16="http://schemas.microsoft.com/office/drawing/2014/main" id="{C4AC6C9D-920D-BEA8-F549-FF5A9F8A070B}"/>
-                  </a:ext>
-                </a:extLst>
-              </p:cNvPr>
-              <p:cNvPicPr>
-                <a:picLocks noChangeAspect="1" noChangeArrowheads="1"/>
-              </p:cNvPicPr>
-              <p:nvPr/>
-            </p:nvPicPr>
-            <p:blipFill rotWithShape="1">
-              <a:blip r:embed="rId10">
-                <a:extLst>
-                  <a:ext uri="{BEBA8EAE-BF5A-486C-A8C5-ECC9F3942E4B}">
-                    <a14:imgProps xmlns:a14="http://schemas.microsoft.com/office/drawing/2010/main">
-                      <a14:imgLayer r:embed="rId11">
-                        <a14:imgEffect>
-                          <a14:backgroundRemoval t="36094" b="56875" l="70775" r="89789">
-                            <a14:foregroundMark x1="83398" y1="36518" x2="84390" y2="36406"/>
-                            <a14:foregroundMark x1="78873" y1="37031" x2="79385" y2="36973"/>
-                            <a14:foregroundMark x1="84390" y1="36406" x2="90023" y2="37500"/>
-                            <a14:foregroundMark x1="90023" y1="37500" x2="88732" y2="52344"/>
-                            <a14:foregroundMark x1="88732" y1="52344" x2="78987" y2="56524"/>
-                            <a14:foregroundMark x1="77013" y1="56515" x2="72653" y2="55156"/>
-                            <a14:foregroundMark x1="72653" y1="55156" x2="71831" y2="49375"/>
-                            <a14:foregroundMark x1="83685" y1="36094" x2="87559" y2="36250"/>
-                            <a14:foregroundMark x1="87911" y1="36719" x2="89789" y2="43906"/>
-                            <a14:foregroundMark x1="89789" y1="43906" x2="88732" y2="43906"/>
-                            <a14:backgroundMark x1="79577" y1="36563" x2="83451" y2="36406"/>
-                            <a14:backgroundMark x1="77934" y1="57813" x2="77934" y2="57813"/>
-                            <a14:backgroundMark x1="78052" y1="57500" x2="78638" y2="57344"/>
-                            <a14:backgroundMark x1="78052" y1="57500" x2="78052" y2="57500"/>
-                            <a14:backgroundMark x1="78052" y1="57500" x2="77700" y2="57656"/>
-                            <a14:backgroundMark x1="78169" y1="57813" x2="78052" y2="57500"/>
-                            <a14:backgroundMark x1="78052" y1="57344" x2="78052" y2="57344"/>
-                            <a14:backgroundMark x1="78286" y1="57813" x2="77934" y2="57656"/>
-                            <a14:backgroundMark x1="78169" y1="57188" x2="77700" y2="57344"/>
-                          </a14:backgroundRemoval>
-                        </a14:imgEffect>
-                      </a14:imgLayer>
-                    </a14:imgProps>
-                  </a:ext>
-                  <a:ext uri="{28A0092B-C50C-407E-A947-70E740481C1C}">
-                    <a14:useLocalDpi xmlns:a14="http://schemas.microsoft.com/office/drawing/2010/main" val="0"/>
-                  </a:ext>
-                </a:extLst>
-              </a:blip>
-              <a:srcRect l="68759" t="35021" r="9163" b="41374"/>
-              <a:stretch>
-                <a:fillRect/>
-              </a:stretch>
-            </p:blipFill>
-            <p:spPr bwMode="auto">
-              <a:xfrm>
-                <a:off x="7203406" y="3164796"/>
-                <a:ext cx="1897627" cy="1524000"/>
-              </a:xfrm>
-              <a:prstGeom prst="rect">
-                <a:avLst/>
-              </a:prstGeom>
-              <a:noFill/>
-              <a:extLst>
-                <a:ext uri="{909E8E84-426E-40DD-AFC4-6F175D3DCCD1}">
-                  <a14:hiddenFill xmlns:a14="http://schemas.microsoft.com/office/drawing/2010/main">
-                    <a:solidFill>
-                      <a:srgbClr val="FFFFFF"/>
-                    </a:solidFill>
-                  </a14:hiddenFill>
-                </a:ext>
-              </a:extLst>
-            </p:spPr>
-          </p:pic>
-          <p:pic>
-            <p:nvPicPr>
-              <p:cNvPr id="54" name="Picture 4">
-                <a:extLst>
-                  <a:ext uri="{FF2B5EF4-FFF2-40B4-BE49-F238E27FC236}">
-                    <a16:creationId xmlns:a16="http://schemas.microsoft.com/office/drawing/2014/main" id="{559C3ED2-9BF4-8384-0090-FED13B4EC30B}"/>
-                  </a:ext>
-                </a:extLst>
-              </p:cNvPr>
-              <p:cNvPicPr>
-                <a:picLocks noChangeAspect="1" noChangeArrowheads="1"/>
-              </p:cNvPicPr>
-              <p:nvPr/>
-            </p:nvPicPr>
-            <p:blipFill rotWithShape="1">
-              <a:blip r:embed="rId12">
-                <a:extLst>
-                  <a:ext uri="{BEBA8EAE-BF5A-486C-A8C5-ECC9F3942E4B}">
-                    <a14:imgProps xmlns:a14="http://schemas.microsoft.com/office/drawing/2010/main">
-                      <a14:imgLayer r:embed="rId13">
-                        <a14:imgEffect>
-                          <a14:backgroundRemoval t="65625" b="96250" l="32512" r="54343">
-                            <a14:foregroundMark x1="32512" y1="77813" x2="33216" y2="74063"/>
-                            <a14:foregroundMark x1="41784" y1="68594" x2="47066" y2="67969"/>
-                            <a14:foregroundMark x1="41315" y1="65781" x2="43192" y2="66250"/>
-                            <a14:foregroundMark x1="54343" y1="78125" x2="54343" y2="78125"/>
-                            <a14:backgroundMark x1="54577" y1="72344" x2="54108" y2="71719"/>
-                          </a14:backgroundRemoval>
-                        </a14:imgEffect>
-                      </a14:imgLayer>
-                    </a14:imgProps>
-                  </a:ext>
-                  <a:ext uri="{28A0092B-C50C-407E-A947-70E740481C1C}">
-                    <a14:useLocalDpi xmlns:a14="http://schemas.microsoft.com/office/drawing/2010/main" val="0"/>
-                  </a:ext>
-                </a:extLst>
-              </a:blip>
-              <a:srcRect l="30337" t="64817" r="43811"/>
-              <a:stretch>
-                <a:fillRect/>
-              </a:stretch>
-            </p:blipFill>
-            <p:spPr bwMode="auto">
-              <a:xfrm>
-                <a:off x="3894145" y="5079044"/>
-                <a:ext cx="2221992" cy="2271524"/>
-              </a:xfrm>
-              <a:prstGeom prst="rect">
-                <a:avLst/>
-              </a:prstGeom>
-              <a:noFill/>
-              <a:extLst>
-                <a:ext uri="{909E8E84-426E-40DD-AFC4-6F175D3DCCD1}">
-                  <a14:hiddenFill xmlns:a14="http://schemas.microsoft.com/office/drawing/2010/main">
-                    <a:solidFill>
-                      <a:srgbClr val="FFFFFF"/>
-                    </a:solidFill>
-                  </a14:hiddenFill>
-                </a:ext>
-              </a:extLst>
-            </p:spPr>
-          </p:pic>
-        </p:grpSp>
-        <p:grpSp>
-          <p:nvGrpSpPr>
-            <p:cNvPr id="33" name="Group 32">
+            </a:blip>
+            <a:srcRect l="8887" t="17100" r="9473" b="15159"/>
+            <a:stretch>
+              <a:fillRect/>
+            </a:stretch>
+          </p:blipFill>
+          <p:spPr bwMode="auto">
+            <a:xfrm>
+              <a:off x="5332830" y="4484157"/>
+              <a:ext cx="1040904" cy="865335"/>
+            </a:xfrm>
+            <a:prstGeom prst="rect">
+              <a:avLst/>
+            </a:prstGeom>
+            <a:noFill/>
+            <a:extLst>
+              <a:ext uri="{909E8E84-426E-40DD-AFC4-6F175D3DCCD1}">
+                <a14:hiddenFill xmlns:a14="http://schemas.microsoft.com/office/drawing/2010/main">
+                  <a:solidFill>
+                    <a:srgbClr val="FFFFFF"/>
+                  </a:solidFill>
+                </a14:hiddenFill>
+              </a:ext>
+            </a:extLst>
+          </p:spPr>
+        </p:pic>
+        <p:pic>
+          <p:nvPicPr>
+            <p:cNvPr id="50" name="Picture 2" descr="solar energy icon logo vector illustration. solar panels symbol ...">
               <a:extLst>
                 <a:ext uri="{FF2B5EF4-FFF2-40B4-BE49-F238E27FC236}">
-                  <a16:creationId xmlns:a16="http://schemas.microsoft.com/office/drawing/2014/main" id="{731D8716-A697-8A1E-347D-61F2D6A8FD5D}"/>
+                  <a16:creationId xmlns:a16="http://schemas.microsoft.com/office/drawing/2014/main" id="{5328724F-5CD4-C8AB-7321-A0B3CB3E3EDB}"/>
                 </a:ext>
               </a:extLst>
             </p:cNvPr>
-            <p:cNvGrpSpPr/>
+            <p:cNvPicPr>
+              <a:picLocks noChangeAspect="1" noChangeArrowheads="1"/>
+            </p:cNvPicPr>
             <p:nvPr/>
-          </p:nvGrpSpPr>
-          <p:grpSpPr>
-            <a:xfrm>
-              <a:off x="5290380" y="4373299"/>
-              <a:ext cx="1040904" cy="962018"/>
-              <a:chOff x="5332830" y="4387474"/>
-              <a:chExt cx="1040904" cy="962018"/>
-            </a:xfrm>
-          </p:grpSpPr>
-          <p:pic>
-            <p:nvPicPr>
-              <p:cNvPr id="49" name="Picture 5">
-                <a:extLst>
-                  <a:ext uri="{FF2B5EF4-FFF2-40B4-BE49-F238E27FC236}">
-                    <a16:creationId xmlns:a16="http://schemas.microsoft.com/office/drawing/2014/main" id="{A7D501B2-6705-DF49-171E-A018ED309F8C}"/>
-                  </a:ext>
-                </a:extLst>
-              </p:cNvPr>
-              <p:cNvPicPr>
-                <a:picLocks noChangeAspect="1" noChangeArrowheads="1"/>
-              </p:cNvPicPr>
-              <p:nvPr/>
-            </p:nvPicPr>
-            <p:blipFill rotWithShape="1">
-              <a:blip r:embed="rId3">
-                <a:extLst>
-                  <a:ext uri="{28A0092B-C50C-407E-A947-70E740481C1C}">
-                    <a14:useLocalDpi xmlns:a14="http://schemas.microsoft.com/office/drawing/2010/main" val="0"/>
-                  </a:ext>
-                </a:extLst>
-              </a:blip>
-              <a:srcRect l="8887" t="17100" r="9473" b="15159"/>
-              <a:stretch>
-                <a:fillRect/>
-              </a:stretch>
-            </p:blipFill>
-            <p:spPr bwMode="auto">
-              <a:xfrm>
-                <a:off x="5332830" y="4484157"/>
-                <a:ext cx="1040904" cy="865335"/>
-              </a:xfrm>
-              <a:prstGeom prst="rect">
-                <a:avLst/>
-              </a:prstGeom>
-              <a:noFill/>
+          </p:nvPicPr>
+          <p:blipFill rotWithShape="1">
+            <a:blip r:embed="rId14">
+              <a:biLevel thresh="50000"/>
               <a:extLst>
-                <a:ext uri="{909E8E84-426E-40DD-AFC4-6F175D3DCCD1}">
-                  <a14:hiddenFill xmlns:a14="http://schemas.microsoft.com/office/drawing/2010/main">
-                    <a:solidFill>
-                      <a:srgbClr val="FFFFFF"/>
-                    </a:solidFill>
-                  </a14:hiddenFill>
+                <a:ext uri="{BEBA8EAE-BF5A-486C-A8C5-ECC9F3942E4B}">
+                  <a14:imgProps xmlns:a14="http://schemas.microsoft.com/office/drawing/2010/main">
+                    <a14:imgLayer r:embed="rId15">
+                      <a14:imgEffect>
+                        <a14:backgroundRemoval t="26458" b="73646" l="21250" r="78750">
+                          <a14:foregroundMark x1="54896" y1="53021" x2="54896" y2="53021"/>
+                          <a14:foregroundMark x1="71146" y1="53542" x2="71146" y2="53542"/>
+                          <a14:foregroundMark x1="64063" y1="70052" x2="64063" y2="70052"/>
+                          <a14:foregroundMark x1="47813" y1="69531" x2="47813" y2="69531"/>
+                          <a14:foregroundMark x1="34115" y1="68229" x2="34115" y2="68229"/>
+                          <a14:foregroundMark x1="33854" y1="40417" x2="33854" y2="40417"/>
+                          <a14:foregroundMark x1="43594" y1="32240" x2="43594" y2="32240"/>
+                          <a14:foregroundMark x1="48333" y1="40938" x2="48333" y2="40938"/>
+                          <a14:foregroundMark x1="23906" y1="51406" x2="23906" y2="51406"/>
+                          <a14:foregroundMark x1="21250" y1="41198" x2="21250" y2="41198"/>
+                          <a14:foregroundMark x1="24948" y1="31979" x2="24948" y2="31979"/>
+                          <a14:foregroundMark x1="34115" y1="26979" x2="34115" y2="26979"/>
+                          <a14:foregroundMark x1="39896" y1="50625" x2="39896" y2="50625"/>
+                          <a14:foregroundMark x1="33854" y1="26458" x2="33854" y2="26458"/>
+                          <a14:foregroundMark x1="34688" y1="28698" x2="34688" y2="28698"/>
+                          <a14:foregroundMark x1="25625" y1="32396" x2="25625" y2="32396"/>
+                          <a14:foregroundMark x1="26042" y1="32292" x2="26042" y2="32292"/>
+                          <a14:foregroundMark x1="24896" y1="50938" x2="24896" y2="50938"/>
+                          <a14:foregroundMark x1="24896" y1="50938" x2="24896" y2="50938"/>
+                          <a14:foregroundMark x1="34688" y1="28073" x2="34688" y2="28073"/>
+                          <a14:foregroundMark x1="34792" y1="29427" x2="34792" y2="29427"/>
+                          <a14:foregroundMark x1="24479" y1="30573" x2="24479" y2="30573"/>
+                        </a14:backgroundRemoval>
+                      </a14:imgEffect>
+                      <a14:imgEffect>
+                        <a14:saturation sat="0"/>
+                      </a14:imgEffect>
+                    </a14:imgLayer>
+                  </a14:imgProps>
+                </a:ext>
+                <a:ext uri="{28A0092B-C50C-407E-A947-70E740481C1C}">
+                  <a14:useLocalDpi xmlns:a14="http://schemas.microsoft.com/office/drawing/2010/main" val="0"/>
                 </a:ext>
               </a:extLst>
-            </p:spPr>
-          </p:pic>
-          <p:pic>
-            <p:nvPicPr>
-              <p:cNvPr id="50" name="Picture 2" descr="solar energy icon logo vector illustration. solar panels symbol ...">
-                <a:extLst>
-                  <a:ext uri="{FF2B5EF4-FFF2-40B4-BE49-F238E27FC236}">
-                    <a16:creationId xmlns:a16="http://schemas.microsoft.com/office/drawing/2014/main" id="{5328724F-5CD4-C8AB-7321-A0B3CB3E3EDB}"/>
-                  </a:ext>
-                </a:extLst>
-              </p:cNvPr>
-              <p:cNvPicPr>
-                <a:picLocks noChangeAspect="1" noChangeArrowheads="1"/>
-              </p:cNvPicPr>
-              <p:nvPr/>
-            </p:nvPicPr>
-            <p:blipFill rotWithShape="1">
-              <a:blip r:embed="rId14">
-                <a:biLevel thresh="50000"/>
-                <a:extLst>
-                  <a:ext uri="{BEBA8EAE-BF5A-486C-A8C5-ECC9F3942E4B}">
-                    <a14:imgProps xmlns:a14="http://schemas.microsoft.com/office/drawing/2010/main">
-                      <a14:imgLayer r:embed="rId15">
-                        <a14:imgEffect>
-                          <a14:backgroundRemoval t="26458" b="73646" l="21250" r="78750">
-                            <a14:foregroundMark x1="54896" y1="53021" x2="54896" y2="53021"/>
-                            <a14:foregroundMark x1="71146" y1="53542" x2="71146" y2="53542"/>
-                            <a14:foregroundMark x1="64063" y1="70052" x2="64063" y2="70052"/>
-                            <a14:foregroundMark x1="47813" y1="69531" x2="47813" y2="69531"/>
-                            <a14:foregroundMark x1="34115" y1="68229" x2="34115" y2="68229"/>
-                            <a14:foregroundMark x1="33854" y1="40417" x2="33854" y2="40417"/>
-                            <a14:foregroundMark x1="43594" y1="32240" x2="43594" y2="32240"/>
-                            <a14:foregroundMark x1="48333" y1="40938" x2="48333" y2="40938"/>
-                            <a14:foregroundMark x1="23906" y1="51406" x2="23906" y2="51406"/>
-                            <a14:foregroundMark x1="21250" y1="41198" x2="21250" y2="41198"/>
-                            <a14:foregroundMark x1="24948" y1="31979" x2="24948" y2="31979"/>
-                            <a14:foregroundMark x1="34115" y1="26979" x2="34115" y2="26979"/>
-                            <a14:foregroundMark x1="39896" y1="50625" x2="39896" y2="50625"/>
-                            <a14:foregroundMark x1="33854" y1="26458" x2="33854" y2="26458"/>
-                            <a14:foregroundMark x1="34688" y1="28698" x2="34688" y2="28698"/>
-                            <a14:foregroundMark x1="25625" y1="32396" x2="25625" y2="32396"/>
-                            <a14:foregroundMark x1="26042" y1="32292" x2="26042" y2="32292"/>
-                            <a14:foregroundMark x1="24896" y1="50938" x2="24896" y2="50938"/>
-                            <a14:foregroundMark x1="24896" y1="50938" x2="24896" y2="50938"/>
-                            <a14:foregroundMark x1="34688" y1="28073" x2="34688" y2="28073"/>
-                            <a14:foregroundMark x1="34792" y1="29427" x2="34792" y2="29427"/>
-                            <a14:foregroundMark x1="24479" y1="30573" x2="24479" y2="30573"/>
-                          </a14:backgroundRemoval>
-                        </a14:imgEffect>
-                        <a14:imgEffect>
-                          <a14:saturation sat="0"/>
-                        </a14:imgEffect>
-                      </a14:imgLayer>
-                    </a14:imgProps>
-                  </a:ext>
-                  <a:ext uri="{28A0092B-C50C-407E-A947-70E740481C1C}">
-                    <a14:useLocalDpi xmlns:a14="http://schemas.microsoft.com/office/drawing/2010/main" val="0"/>
-                  </a:ext>
-                </a:extLst>
-              </a:blip>
-              <a:srcRect l="14807" t="21993" r="14052" b="20615"/>
-              <a:stretch>
-                <a:fillRect/>
-              </a:stretch>
-            </p:blipFill>
-            <p:spPr bwMode="auto">
-              <a:xfrm>
-                <a:off x="5370924" y="4387474"/>
-                <a:ext cx="507750" cy="409620"/>
-              </a:xfrm>
-              <a:prstGeom prst="rect">
-                <a:avLst/>
-              </a:prstGeom>
-              <a:noFill/>
-              <a:extLst>
-                <a:ext uri="{909E8E84-426E-40DD-AFC4-6F175D3DCCD1}">
-                  <a14:hiddenFill xmlns:a14="http://schemas.microsoft.com/office/drawing/2010/main">
-                    <a:solidFill>
-                      <a:srgbClr val="FFFFFF"/>
-                    </a:solidFill>
-                  </a14:hiddenFill>
-                </a:ext>
-              </a:extLst>
-            </p:spPr>
-          </p:pic>
-        </p:grpSp>
-        <p:grpSp>
-          <p:nvGrpSpPr>
-            <p:cNvPr id="36" name="Group 35">
+            </a:blip>
+            <a:srcRect l="14807" t="21993" r="14052" b="20615"/>
+            <a:stretch>
+              <a:fillRect/>
+            </a:stretch>
+          </p:blipFill>
+          <p:spPr bwMode="auto">
+            <a:xfrm>
+              <a:off x="5370924" y="4387474"/>
+              <a:ext cx="507750" cy="409620"/>
+            </a:xfrm>
+            <a:prstGeom prst="rect">
+              <a:avLst/>
+            </a:prstGeom>
+            <a:noFill/>
+            <a:extLst>
+              <a:ext uri="{909E8E84-426E-40DD-AFC4-6F175D3DCCD1}">
+                <a14:hiddenFill xmlns:a14="http://schemas.microsoft.com/office/drawing/2010/main">
+                  <a:solidFill>
+                    <a:srgbClr val="FFFFFF"/>
+                  </a:solidFill>
+                </a14:hiddenFill>
+              </a:ext>
+            </a:extLst>
+          </p:spPr>
+        </p:pic>
+      </p:grpSp>
+      <p:grpSp>
+        <p:nvGrpSpPr>
+          <p:cNvPr id="36" name="Group 35">
+            <a:extLst>
+              <a:ext uri="{FF2B5EF4-FFF2-40B4-BE49-F238E27FC236}">
+                <a16:creationId xmlns:a16="http://schemas.microsoft.com/office/drawing/2014/main" id="{7D1CAB4D-F681-0D40-FDF8-981C0AE9BC9A}"/>
+              </a:ext>
+            </a:extLst>
+          </p:cNvPr>
+          <p:cNvGrpSpPr/>
+          <p:nvPr/>
+        </p:nvGrpSpPr>
+        <p:grpSpPr>
+          <a:xfrm>
+            <a:off x="366105" y="4750594"/>
+            <a:ext cx="1066691" cy="985850"/>
+            <a:chOff x="5332830" y="4387474"/>
+            <a:chExt cx="1040904" cy="962018"/>
+          </a:xfrm>
+        </p:grpSpPr>
+        <p:pic>
+          <p:nvPicPr>
+            <p:cNvPr id="47" name="Picture 5">
               <a:extLst>
                 <a:ext uri="{FF2B5EF4-FFF2-40B4-BE49-F238E27FC236}">
-                  <a16:creationId xmlns:a16="http://schemas.microsoft.com/office/drawing/2014/main" id="{7D1CAB4D-F681-0D40-FDF8-981C0AE9BC9A}"/>
+                  <a16:creationId xmlns:a16="http://schemas.microsoft.com/office/drawing/2014/main" id="{63A4EBF5-A0C5-3B99-1F2C-4E1318591672}"/>
                 </a:ext>
               </a:extLst>
             </p:cNvPr>
-            <p:cNvGrpSpPr/>
+            <p:cNvPicPr>
+              <a:picLocks noChangeAspect="1" noChangeArrowheads="1"/>
+            </p:cNvPicPr>
             <p:nvPr/>
-          </p:nvGrpSpPr>
-          <p:grpSpPr>
-            <a:xfrm>
-              <a:off x="336001" y="4867916"/>
-              <a:ext cx="1040904" cy="962018"/>
-              <a:chOff x="5332830" y="4387474"/>
-              <a:chExt cx="1040904" cy="962018"/>
-            </a:xfrm>
-          </p:grpSpPr>
-          <p:pic>
-            <p:nvPicPr>
-              <p:cNvPr id="47" name="Picture 5">
-                <a:extLst>
-                  <a:ext uri="{FF2B5EF4-FFF2-40B4-BE49-F238E27FC236}">
-                    <a16:creationId xmlns:a16="http://schemas.microsoft.com/office/drawing/2014/main" id="{63A4EBF5-A0C5-3B99-1F2C-4E1318591672}"/>
-                  </a:ext>
-                </a:extLst>
-              </p:cNvPr>
-              <p:cNvPicPr>
-                <a:picLocks noChangeAspect="1" noChangeArrowheads="1"/>
-              </p:cNvPicPr>
-              <p:nvPr/>
-            </p:nvPicPr>
-            <p:blipFill rotWithShape="1">
-              <a:blip r:embed="rId3">
-                <a:extLst>
-                  <a:ext uri="{28A0092B-C50C-407E-A947-70E740481C1C}">
-                    <a14:useLocalDpi xmlns:a14="http://schemas.microsoft.com/office/drawing/2010/main" val="0"/>
-                  </a:ext>
-                </a:extLst>
-              </a:blip>
-              <a:srcRect l="8887" t="17100" r="9473" b="15159"/>
-              <a:stretch>
-                <a:fillRect/>
-              </a:stretch>
-            </p:blipFill>
-            <p:spPr bwMode="auto">
-              <a:xfrm>
-                <a:off x="5332830" y="4484157"/>
-                <a:ext cx="1040904" cy="865335"/>
-              </a:xfrm>
-              <a:prstGeom prst="rect">
-                <a:avLst/>
-              </a:prstGeom>
-              <a:noFill/>
+          </p:nvPicPr>
+          <p:blipFill rotWithShape="1">
+            <a:blip r:embed="rId3">
               <a:extLst>
-                <a:ext uri="{909E8E84-426E-40DD-AFC4-6F175D3DCCD1}">
-                  <a14:hiddenFill xmlns:a14="http://schemas.microsoft.com/office/drawing/2010/main">
-                    <a:solidFill>
-                      <a:srgbClr val="FFFFFF"/>
-                    </a:solidFill>
-                  </a14:hiddenFill>
+                <a:ext uri="{28A0092B-C50C-407E-A947-70E740481C1C}">
+                  <a14:useLocalDpi xmlns:a14="http://schemas.microsoft.com/office/drawing/2010/main" val="0"/>
                 </a:ext>
               </a:extLst>
-            </p:spPr>
-          </p:pic>
-          <p:pic>
-            <p:nvPicPr>
-              <p:cNvPr id="48" name="Picture 2" descr="solar energy icon logo vector illustration. solar panels symbol ...">
-                <a:extLst>
-                  <a:ext uri="{FF2B5EF4-FFF2-40B4-BE49-F238E27FC236}">
-                    <a16:creationId xmlns:a16="http://schemas.microsoft.com/office/drawing/2014/main" id="{D4726B13-CAAB-F6C5-0D20-A53E5DD3AFEB}"/>
-                  </a:ext>
-                </a:extLst>
-              </p:cNvPr>
-              <p:cNvPicPr>
-                <a:picLocks noChangeAspect="1" noChangeArrowheads="1"/>
-              </p:cNvPicPr>
-              <p:nvPr/>
-            </p:nvPicPr>
-            <p:blipFill rotWithShape="1">
-              <a:blip r:embed="rId14">
-                <a:biLevel thresh="25000"/>
-                <a:extLst>
-                  <a:ext uri="{BEBA8EAE-BF5A-486C-A8C5-ECC9F3942E4B}">
-                    <a14:imgProps xmlns:a14="http://schemas.microsoft.com/office/drawing/2010/main">
-                      <a14:imgLayer r:embed="rId5">
-                        <a14:imgEffect>
-                          <a14:backgroundRemoval t="26458" b="73646" l="21250" r="78750">
-                            <a14:foregroundMark x1="54896" y1="53021" x2="54896" y2="53021"/>
-                            <a14:foregroundMark x1="71146" y1="53542" x2="71146" y2="53542"/>
-                            <a14:foregroundMark x1="64063" y1="70052" x2="64063" y2="70052"/>
-                            <a14:foregroundMark x1="47813" y1="69531" x2="47813" y2="69531"/>
-                            <a14:foregroundMark x1="34115" y1="68229" x2="34115" y2="68229"/>
-                            <a14:foregroundMark x1="33854" y1="40417" x2="33854" y2="40417"/>
-                            <a14:foregroundMark x1="43594" y1="32240" x2="43594" y2="32240"/>
-                            <a14:foregroundMark x1="48333" y1="40938" x2="48333" y2="40938"/>
-                            <a14:foregroundMark x1="23906" y1="51406" x2="23906" y2="51406"/>
-                            <a14:foregroundMark x1="21250" y1="41198" x2="21250" y2="41198"/>
-                            <a14:foregroundMark x1="24948" y1="31979" x2="24948" y2="31979"/>
-                            <a14:foregroundMark x1="34115" y1="26979" x2="34115" y2="26979"/>
-                            <a14:foregroundMark x1="39896" y1="50625" x2="39896" y2="50625"/>
-                            <a14:foregroundMark x1="33854" y1="26458" x2="33854" y2="26458"/>
-                            <a14:foregroundMark x1="34688" y1="28698" x2="34688" y2="28698"/>
-                            <a14:foregroundMark x1="25625" y1="32396" x2="25625" y2="32396"/>
-                            <a14:foregroundMark x1="26042" y1="32292" x2="26042" y2="32292"/>
-                            <a14:foregroundMark x1="24896" y1="50938" x2="24896" y2="50938"/>
-                            <a14:foregroundMark x1="24896" y1="50938" x2="24896" y2="50938"/>
-                            <a14:foregroundMark x1="34688" y1="28073" x2="34688" y2="28073"/>
-                            <a14:foregroundMark x1="34792" y1="29427" x2="34792" y2="29427"/>
-                            <a14:foregroundMark x1="24479" y1="30573" x2="24479" y2="30573"/>
-                          </a14:backgroundRemoval>
-                        </a14:imgEffect>
-                        <a14:imgEffect>
-                          <a14:saturation sat="0"/>
-                        </a14:imgEffect>
-                      </a14:imgLayer>
-                    </a14:imgProps>
-                  </a:ext>
-                  <a:ext uri="{28A0092B-C50C-407E-A947-70E740481C1C}">
-                    <a14:useLocalDpi xmlns:a14="http://schemas.microsoft.com/office/drawing/2010/main" val="0"/>
-                  </a:ext>
-                </a:extLst>
-              </a:blip>
-              <a:srcRect l="14807" t="21993" r="14052" b="20615"/>
-              <a:stretch>
-                <a:fillRect/>
-              </a:stretch>
-            </p:blipFill>
-            <p:spPr bwMode="auto">
-              <a:xfrm>
-                <a:off x="5370924" y="4387474"/>
-                <a:ext cx="507750" cy="409620"/>
-              </a:xfrm>
-              <a:prstGeom prst="rect">
-                <a:avLst/>
-              </a:prstGeom>
-              <a:noFill/>
-              <a:extLst>
-                <a:ext uri="{909E8E84-426E-40DD-AFC4-6F175D3DCCD1}">
-                  <a14:hiddenFill xmlns:a14="http://schemas.microsoft.com/office/drawing/2010/main">
-                    <a:solidFill>
-                      <a:srgbClr val="FFFFFF"/>
-                    </a:solidFill>
-                  </a14:hiddenFill>
-                </a:ext>
-              </a:extLst>
-            </p:spPr>
-          </p:pic>
-        </p:grpSp>
-        <p:grpSp>
-          <p:nvGrpSpPr>
-            <p:cNvPr id="37" name="Group 36">
+            </a:blip>
+            <a:srcRect l="8887" t="17100" r="9473" b="15159"/>
+            <a:stretch>
+              <a:fillRect/>
+            </a:stretch>
+          </p:blipFill>
+          <p:spPr bwMode="auto">
+            <a:xfrm>
+              <a:off x="5332830" y="4484157"/>
+              <a:ext cx="1040904" cy="865335"/>
+            </a:xfrm>
+            <a:prstGeom prst="rect">
+              <a:avLst/>
+            </a:prstGeom>
+            <a:noFill/>
+            <a:extLst>
+              <a:ext uri="{909E8E84-426E-40DD-AFC4-6F175D3DCCD1}">
+                <a14:hiddenFill xmlns:a14="http://schemas.microsoft.com/office/drawing/2010/main">
+                  <a:solidFill>
+                    <a:srgbClr val="FFFFFF"/>
+                  </a:solidFill>
+                </a14:hiddenFill>
+              </a:ext>
+            </a:extLst>
+          </p:spPr>
+        </p:pic>
+        <p:pic>
+          <p:nvPicPr>
+            <p:cNvPr id="48" name="Picture 2" descr="solar energy icon logo vector illustration. solar panels symbol ...">
               <a:extLst>
                 <a:ext uri="{FF2B5EF4-FFF2-40B4-BE49-F238E27FC236}">
-                  <a16:creationId xmlns:a16="http://schemas.microsoft.com/office/drawing/2014/main" id="{43E7B9A4-4FBA-0EC5-0C5B-45FD8FBFA579}"/>
+                  <a16:creationId xmlns:a16="http://schemas.microsoft.com/office/drawing/2014/main" id="{D4726B13-CAAB-F6C5-0D20-A53E5DD3AFEB}"/>
                 </a:ext>
               </a:extLst>
             </p:cNvPr>
-            <p:cNvGrpSpPr/>
+            <p:cNvPicPr>
+              <a:picLocks noChangeAspect="1" noChangeArrowheads="1"/>
+            </p:cNvPicPr>
             <p:nvPr/>
-          </p:nvGrpSpPr>
-          <p:grpSpPr>
-            <a:xfrm>
-              <a:off x="2365794" y="5845973"/>
-              <a:ext cx="1040904" cy="962018"/>
-              <a:chOff x="5332830" y="4387474"/>
-              <a:chExt cx="1040904" cy="962018"/>
-            </a:xfrm>
-          </p:grpSpPr>
-          <p:pic>
-            <p:nvPicPr>
-              <p:cNvPr id="40" name="Picture 5">
-                <a:extLst>
-                  <a:ext uri="{FF2B5EF4-FFF2-40B4-BE49-F238E27FC236}">
-                    <a16:creationId xmlns:a16="http://schemas.microsoft.com/office/drawing/2014/main" id="{6167ACA3-B189-E30D-72B9-FF64B0A58266}"/>
-                  </a:ext>
-                </a:extLst>
-              </p:cNvPr>
-              <p:cNvPicPr>
-                <a:picLocks noChangeAspect="1" noChangeArrowheads="1"/>
-              </p:cNvPicPr>
-              <p:nvPr/>
-            </p:nvPicPr>
-            <p:blipFill rotWithShape="1">
-              <a:blip r:embed="rId3">
-                <a:extLst>
-                  <a:ext uri="{28A0092B-C50C-407E-A947-70E740481C1C}">
-                    <a14:useLocalDpi xmlns:a14="http://schemas.microsoft.com/office/drawing/2010/main" val="0"/>
-                  </a:ext>
-                </a:extLst>
-              </a:blip>
-              <a:srcRect l="8887" t="17100" r="9473" b="15159"/>
-              <a:stretch>
-                <a:fillRect/>
-              </a:stretch>
-            </p:blipFill>
-            <p:spPr bwMode="auto">
-              <a:xfrm>
-                <a:off x="5332830" y="4484157"/>
-                <a:ext cx="1040904" cy="865335"/>
-              </a:xfrm>
-              <a:prstGeom prst="rect">
-                <a:avLst/>
-              </a:prstGeom>
-              <a:noFill/>
+          </p:nvPicPr>
+          <p:blipFill rotWithShape="1">
+            <a:blip r:embed="rId14">
+              <a:biLevel thresh="25000"/>
               <a:extLst>
-                <a:ext uri="{909E8E84-426E-40DD-AFC4-6F175D3DCCD1}">
-                  <a14:hiddenFill xmlns:a14="http://schemas.microsoft.com/office/drawing/2010/main">
-                    <a:solidFill>
-                      <a:srgbClr val="FFFFFF"/>
-                    </a:solidFill>
-                  </a14:hiddenFill>
+                <a:ext uri="{BEBA8EAE-BF5A-486C-A8C5-ECC9F3942E4B}">
+                  <a14:imgProps xmlns:a14="http://schemas.microsoft.com/office/drawing/2010/main">
+                    <a14:imgLayer r:embed="rId5">
+                      <a14:imgEffect>
+                        <a14:backgroundRemoval t="26458" b="73646" l="21250" r="78750">
+                          <a14:foregroundMark x1="54896" y1="53021" x2="54896" y2="53021"/>
+                          <a14:foregroundMark x1="71146" y1="53542" x2="71146" y2="53542"/>
+                          <a14:foregroundMark x1="64063" y1="70052" x2="64063" y2="70052"/>
+                          <a14:foregroundMark x1="47813" y1="69531" x2="47813" y2="69531"/>
+                          <a14:foregroundMark x1="34115" y1="68229" x2="34115" y2="68229"/>
+                          <a14:foregroundMark x1="33854" y1="40417" x2="33854" y2="40417"/>
+                          <a14:foregroundMark x1="43594" y1="32240" x2="43594" y2="32240"/>
+                          <a14:foregroundMark x1="48333" y1="40938" x2="48333" y2="40938"/>
+                          <a14:foregroundMark x1="23906" y1="51406" x2="23906" y2="51406"/>
+                          <a14:foregroundMark x1="21250" y1="41198" x2="21250" y2="41198"/>
+                          <a14:foregroundMark x1="24948" y1="31979" x2="24948" y2="31979"/>
+                          <a14:foregroundMark x1="34115" y1="26979" x2="34115" y2="26979"/>
+                          <a14:foregroundMark x1="39896" y1="50625" x2="39896" y2="50625"/>
+                          <a14:foregroundMark x1="33854" y1="26458" x2="33854" y2="26458"/>
+                          <a14:foregroundMark x1="34688" y1="28698" x2="34688" y2="28698"/>
+                          <a14:foregroundMark x1="25625" y1="32396" x2="25625" y2="32396"/>
+                          <a14:foregroundMark x1="26042" y1="32292" x2="26042" y2="32292"/>
+                          <a14:foregroundMark x1="24896" y1="50938" x2="24896" y2="50938"/>
+                          <a14:foregroundMark x1="24896" y1="50938" x2="24896" y2="50938"/>
+                          <a14:foregroundMark x1="34688" y1="28073" x2="34688" y2="28073"/>
+                          <a14:foregroundMark x1="34792" y1="29427" x2="34792" y2="29427"/>
+                          <a14:foregroundMark x1="24479" y1="30573" x2="24479" y2="30573"/>
+                        </a14:backgroundRemoval>
+                      </a14:imgEffect>
+                      <a14:imgEffect>
+                        <a14:saturation sat="0"/>
+                      </a14:imgEffect>
+                    </a14:imgLayer>
+                  </a14:imgProps>
+                </a:ext>
+                <a:ext uri="{28A0092B-C50C-407E-A947-70E740481C1C}">
+                  <a14:useLocalDpi xmlns:a14="http://schemas.microsoft.com/office/drawing/2010/main" val="0"/>
                 </a:ext>
               </a:extLst>
-            </p:spPr>
-          </p:pic>
-          <p:pic>
-            <p:nvPicPr>
-              <p:cNvPr id="41" name="Picture 2" descr="solar energy icon logo vector illustration. solar panels symbol ...">
-                <a:extLst>
-                  <a:ext uri="{FF2B5EF4-FFF2-40B4-BE49-F238E27FC236}">
-                    <a16:creationId xmlns:a16="http://schemas.microsoft.com/office/drawing/2014/main" id="{12E54575-8A86-EB76-386A-FE0E04325FA9}"/>
-                  </a:ext>
-                </a:extLst>
-              </p:cNvPr>
-              <p:cNvPicPr>
-                <a:picLocks noChangeAspect="1" noChangeArrowheads="1"/>
-              </p:cNvPicPr>
-              <p:nvPr/>
-            </p:nvPicPr>
-            <p:blipFill rotWithShape="1">
-              <a:blip r:embed="rId14">
-                <a:biLevel thresh="25000"/>
-                <a:extLst>
-                  <a:ext uri="{BEBA8EAE-BF5A-486C-A8C5-ECC9F3942E4B}">
-                    <a14:imgProps xmlns:a14="http://schemas.microsoft.com/office/drawing/2010/main">
-                      <a14:imgLayer r:embed="rId5">
-                        <a14:imgEffect>
-                          <a14:backgroundRemoval t="26458" b="73646" l="21250" r="78750">
-                            <a14:foregroundMark x1="54896" y1="53021" x2="54896" y2="53021"/>
-                            <a14:foregroundMark x1="71146" y1="53542" x2="71146" y2="53542"/>
-                            <a14:foregroundMark x1="64063" y1="70052" x2="64063" y2="70052"/>
-                            <a14:foregroundMark x1="47813" y1="69531" x2="47813" y2="69531"/>
-                            <a14:foregroundMark x1="34115" y1="68229" x2="34115" y2="68229"/>
-                            <a14:foregroundMark x1="33854" y1="40417" x2="33854" y2="40417"/>
-                            <a14:foregroundMark x1="43594" y1="32240" x2="43594" y2="32240"/>
-                            <a14:foregroundMark x1="48333" y1="40938" x2="48333" y2="40938"/>
-                            <a14:foregroundMark x1="23906" y1="51406" x2="23906" y2="51406"/>
-                            <a14:foregroundMark x1="21250" y1="41198" x2="21250" y2="41198"/>
-                            <a14:foregroundMark x1="24948" y1="31979" x2="24948" y2="31979"/>
-                            <a14:foregroundMark x1="34115" y1="26979" x2="34115" y2="26979"/>
-                            <a14:foregroundMark x1="39896" y1="50625" x2="39896" y2="50625"/>
-                            <a14:foregroundMark x1="33854" y1="26458" x2="33854" y2="26458"/>
-                            <a14:foregroundMark x1="34688" y1="28698" x2="34688" y2="28698"/>
-                            <a14:foregroundMark x1="25625" y1="32396" x2="25625" y2="32396"/>
-                            <a14:foregroundMark x1="26042" y1="32292" x2="26042" y2="32292"/>
-                            <a14:foregroundMark x1="24896" y1="50938" x2="24896" y2="50938"/>
-                            <a14:foregroundMark x1="24896" y1="50938" x2="24896" y2="50938"/>
-                            <a14:foregroundMark x1="34688" y1="28073" x2="34688" y2="28073"/>
-                            <a14:foregroundMark x1="34792" y1="29427" x2="34792" y2="29427"/>
-                            <a14:foregroundMark x1="24479" y1="30573" x2="24479" y2="30573"/>
-                          </a14:backgroundRemoval>
-                        </a14:imgEffect>
-                        <a14:imgEffect>
-                          <a14:saturation sat="0"/>
-                        </a14:imgEffect>
-                      </a14:imgLayer>
-                    </a14:imgProps>
-                  </a:ext>
-                  <a:ext uri="{28A0092B-C50C-407E-A947-70E740481C1C}">
-                    <a14:useLocalDpi xmlns:a14="http://schemas.microsoft.com/office/drawing/2010/main" val="0"/>
-                  </a:ext>
-                </a:extLst>
-              </a:blip>
-              <a:srcRect l="14807" t="21993" r="14052" b="20615"/>
-              <a:stretch>
-                <a:fillRect/>
-              </a:stretch>
-            </p:blipFill>
-            <p:spPr bwMode="auto">
-              <a:xfrm>
-                <a:off x="5370924" y="4387474"/>
-                <a:ext cx="507750" cy="409620"/>
-              </a:xfrm>
-              <a:prstGeom prst="rect">
-                <a:avLst/>
-              </a:prstGeom>
-              <a:noFill/>
+            </a:blip>
+            <a:srcRect l="14807" t="21993" r="14052" b="20615"/>
+            <a:stretch>
+              <a:fillRect/>
+            </a:stretch>
+          </p:blipFill>
+          <p:spPr bwMode="auto">
+            <a:xfrm>
+              <a:off x="5370924" y="4387474"/>
+              <a:ext cx="507750" cy="409620"/>
+            </a:xfrm>
+            <a:prstGeom prst="rect">
+              <a:avLst/>
+            </a:prstGeom>
+            <a:noFill/>
+            <a:extLst>
+              <a:ext uri="{909E8E84-426E-40DD-AFC4-6F175D3DCCD1}">
+                <a14:hiddenFill xmlns:a14="http://schemas.microsoft.com/office/drawing/2010/main">
+                  <a:solidFill>
+                    <a:srgbClr val="FFFFFF"/>
+                  </a:solidFill>
+                </a14:hiddenFill>
+              </a:ext>
+            </a:extLst>
+          </p:spPr>
+        </p:pic>
+      </p:grpSp>
+      <p:grpSp>
+        <p:nvGrpSpPr>
+          <p:cNvPr id="37" name="Group 36">
+            <a:extLst>
+              <a:ext uri="{FF2B5EF4-FFF2-40B4-BE49-F238E27FC236}">
+                <a16:creationId xmlns:a16="http://schemas.microsoft.com/office/drawing/2014/main" id="{43E7B9A4-4FBA-0EC5-0C5B-45FD8FBFA579}"/>
+              </a:ext>
+            </a:extLst>
+          </p:cNvPr>
+          <p:cNvGrpSpPr/>
+          <p:nvPr/>
+        </p:nvGrpSpPr>
+        <p:grpSpPr>
+          <a:xfrm>
+            <a:off x="2446183" y="5752881"/>
+            <a:ext cx="1066691" cy="985850"/>
+            <a:chOff x="5332830" y="4387474"/>
+            <a:chExt cx="1040904" cy="962018"/>
+          </a:xfrm>
+        </p:grpSpPr>
+        <p:pic>
+          <p:nvPicPr>
+            <p:cNvPr id="40" name="Picture 5">
               <a:extLst>
-                <a:ext uri="{909E8E84-426E-40DD-AFC4-6F175D3DCCD1}">
-                  <a14:hiddenFill xmlns:a14="http://schemas.microsoft.com/office/drawing/2010/main">
-                    <a:solidFill>
-                      <a:srgbClr val="FFFFFF"/>
-                    </a:solidFill>
-                  </a14:hiddenFill>
+                <a:ext uri="{FF2B5EF4-FFF2-40B4-BE49-F238E27FC236}">
+                  <a16:creationId xmlns:a16="http://schemas.microsoft.com/office/drawing/2014/main" id="{6167ACA3-B189-E30D-72B9-FF64B0A58266}"/>
                 </a:ext>
               </a:extLst>
-            </p:spPr>
-          </p:pic>
-        </p:grpSp>
+            </p:cNvPr>
+            <p:cNvPicPr>
+              <a:picLocks noChangeAspect="1" noChangeArrowheads="1"/>
+            </p:cNvPicPr>
+            <p:nvPr/>
+          </p:nvPicPr>
+          <p:blipFill rotWithShape="1">
+            <a:blip r:embed="rId3">
+              <a:extLst>
+                <a:ext uri="{28A0092B-C50C-407E-A947-70E740481C1C}">
+                  <a14:useLocalDpi xmlns:a14="http://schemas.microsoft.com/office/drawing/2010/main" val="0"/>
+                </a:ext>
+              </a:extLst>
+            </a:blip>
+            <a:srcRect l="8887" t="17100" r="9473" b="15159"/>
+            <a:stretch>
+              <a:fillRect/>
+            </a:stretch>
+          </p:blipFill>
+          <p:spPr bwMode="auto">
+            <a:xfrm>
+              <a:off x="5332830" y="4484157"/>
+              <a:ext cx="1040904" cy="865335"/>
+            </a:xfrm>
+            <a:prstGeom prst="rect">
+              <a:avLst/>
+            </a:prstGeom>
+            <a:noFill/>
+            <a:extLst>
+              <a:ext uri="{909E8E84-426E-40DD-AFC4-6F175D3DCCD1}">
+                <a14:hiddenFill xmlns:a14="http://schemas.microsoft.com/office/drawing/2010/main">
+                  <a:solidFill>
+                    <a:srgbClr val="FFFFFF"/>
+                  </a:solidFill>
+                </a14:hiddenFill>
+              </a:ext>
+            </a:extLst>
+          </p:spPr>
+        </p:pic>
+        <p:pic>
+          <p:nvPicPr>
+            <p:cNvPr id="41" name="Picture 2" descr="solar energy icon logo vector illustration. solar panels symbol ...">
+              <a:extLst>
+                <a:ext uri="{FF2B5EF4-FFF2-40B4-BE49-F238E27FC236}">
+                  <a16:creationId xmlns:a16="http://schemas.microsoft.com/office/drawing/2014/main" id="{12E54575-8A86-EB76-386A-FE0E04325FA9}"/>
+                </a:ext>
+              </a:extLst>
+            </p:cNvPr>
+            <p:cNvPicPr>
+              <a:picLocks noChangeAspect="1" noChangeArrowheads="1"/>
+            </p:cNvPicPr>
+            <p:nvPr/>
+          </p:nvPicPr>
+          <p:blipFill rotWithShape="1">
+            <a:blip r:embed="rId14">
+              <a:biLevel thresh="25000"/>
+              <a:extLst>
+                <a:ext uri="{BEBA8EAE-BF5A-486C-A8C5-ECC9F3942E4B}">
+                  <a14:imgProps xmlns:a14="http://schemas.microsoft.com/office/drawing/2010/main">
+                    <a14:imgLayer r:embed="rId5">
+                      <a14:imgEffect>
+                        <a14:backgroundRemoval t="26458" b="73646" l="21250" r="78750">
+                          <a14:foregroundMark x1="54896" y1="53021" x2="54896" y2="53021"/>
+                          <a14:foregroundMark x1="71146" y1="53542" x2="71146" y2="53542"/>
+                          <a14:foregroundMark x1="64063" y1="70052" x2="64063" y2="70052"/>
+                          <a14:foregroundMark x1="47813" y1="69531" x2="47813" y2="69531"/>
+                          <a14:foregroundMark x1="34115" y1="68229" x2="34115" y2="68229"/>
+                          <a14:foregroundMark x1="33854" y1="40417" x2="33854" y2="40417"/>
+                          <a14:foregroundMark x1="43594" y1="32240" x2="43594" y2="32240"/>
+                          <a14:foregroundMark x1="48333" y1="40938" x2="48333" y2="40938"/>
+                          <a14:foregroundMark x1="23906" y1="51406" x2="23906" y2="51406"/>
+                          <a14:foregroundMark x1="21250" y1="41198" x2="21250" y2="41198"/>
+                          <a14:foregroundMark x1="24948" y1="31979" x2="24948" y2="31979"/>
+                          <a14:foregroundMark x1="34115" y1="26979" x2="34115" y2="26979"/>
+                          <a14:foregroundMark x1="39896" y1="50625" x2="39896" y2="50625"/>
+                          <a14:foregroundMark x1="33854" y1="26458" x2="33854" y2="26458"/>
+                          <a14:foregroundMark x1="34688" y1="28698" x2="34688" y2="28698"/>
+                          <a14:foregroundMark x1="25625" y1="32396" x2="25625" y2="32396"/>
+                          <a14:foregroundMark x1="26042" y1="32292" x2="26042" y2="32292"/>
+                          <a14:foregroundMark x1="24896" y1="50938" x2="24896" y2="50938"/>
+                          <a14:foregroundMark x1="24896" y1="50938" x2="24896" y2="50938"/>
+                          <a14:foregroundMark x1="34688" y1="28073" x2="34688" y2="28073"/>
+                          <a14:foregroundMark x1="34792" y1="29427" x2="34792" y2="29427"/>
+                          <a14:foregroundMark x1="24479" y1="30573" x2="24479" y2="30573"/>
+                        </a14:backgroundRemoval>
+                      </a14:imgEffect>
+                      <a14:imgEffect>
+                        <a14:saturation sat="0"/>
+                      </a14:imgEffect>
+                    </a14:imgLayer>
+                  </a14:imgProps>
+                </a:ext>
+                <a:ext uri="{28A0092B-C50C-407E-A947-70E740481C1C}">
+                  <a14:useLocalDpi xmlns:a14="http://schemas.microsoft.com/office/drawing/2010/main" val="0"/>
+                </a:ext>
+              </a:extLst>
+            </a:blip>
+            <a:srcRect l="14807" t="21993" r="14052" b="20615"/>
+            <a:stretch>
+              <a:fillRect/>
+            </a:stretch>
+          </p:blipFill>
+          <p:spPr bwMode="auto">
+            <a:xfrm>
+              <a:off x="5370924" y="4387474"/>
+              <a:ext cx="507750" cy="409620"/>
+            </a:xfrm>
+            <a:prstGeom prst="rect">
+              <a:avLst/>
+            </a:prstGeom>
+            <a:noFill/>
+            <a:extLst>
+              <a:ext uri="{909E8E84-426E-40DD-AFC4-6F175D3DCCD1}">
+                <a14:hiddenFill xmlns:a14="http://schemas.microsoft.com/office/drawing/2010/main">
+                  <a:solidFill>
+                    <a:srgbClr val="FFFFFF"/>
+                  </a:solidFill>
+                </a14:hiddenFill>
+              </a:ext>
+            </a:extLst>
+          </p:spPr>
+        </p:pic>
       </p:grpSp>
       <p:sp>
         <p:nvSpPr>

</xml_diff>